<commit_message>
Fill every slide of the defence presentation with content
Previously only the title slide had the CampusFit title; slides 2-7
carried bare template headings (Introduction, Aims and Objectives, etc.)
with no body. Now each slide carries its full defence content:
- Slide 1: CampusFit title + NAME/ID/SUPERVISOR placeholders + date.
- Slide 2: Outline (7 topics).
- Slide 3: Introduction (problem, gap, contribution, 3 citations).
- Slide 4: Aims and Objectives (aim + 10 specific objectives).
- Slide 5: Related Work (SDT, flow, sustainability, Pokemon Go, attrition,
  why not sensors alone).
- Slide 6: Proposed Solution (3-tier architecture + scan_checkpoint()
  reward economy + multipliers).
- Slide 7: End Slide (thank you + 6 verified findings + future work).
- Slide 8: Closing (THANK YOU - Q&A + NAME/ID/SUPERVISOR + date).

Template master, banner, date and page numbers left untouched.
</commit_message>
<xml_diff>
--- a/CampusFit_Project_Defence.pptx
+++ b/CampusFit_Project_Defence.pptx
@@ -9621,7 +9621,14 @@
                 <a:ea typeface="Times New Roman" panose="02020603050405020304" pitchFamily="18" charset="0"/>
                 <a:sym typeface="+mn-ea"/>
               </a:rPr>
-              <a:t>OUTLINE OF  PRESENTATION</a:t>
+              <a:t>OUTLINE OF  PRESENTATION
+Problem and motivation
+Research aim, questions and objectives
+Literature and theoretical framework
+Methodology and design
+System architecture and implementation
+Evaluation: verification, fidelity, performance, reward economy
+Findings, contributions and future work</a:t>
             </a:r>
             <a:endParaRPr lang="en-US" dirty="0"/>
           </a:p>
@@ -9802,7 +9809,22 @@
                 <a:latin typeface="Times New Roman" panose="02020603050405020304" pitchFamily="18" charset="0"/>
                 <a:cs typeface="Times New Roman" panose="02020603050405020304" pitchFamily="18" charset="0"/>
               </a:rPr>
-              <a:t>Introduction</a:t>
+              <a:t>Introduction
+University students are among the least active populations: nearly half
+inactive in sampled cohorts (Alkhawaldeh et al., 2024); 22.4%
+insufficiently active (Edelmann et al., 2022).
+Generic fitness apps count steps but do not engage the campus
+environment students actually live and move through (McCallum et al., 2018).
+Gamification increases physical activity, but heterogeneously, and with
+documented risks in purely competitive designs (Hamari et al., 2014;
+Mazeas et al., 2022; Nishi et al., 2024).
+Research gap: no reviewed system combines campus-anchored checkpoints,
+server-side auditable reward allocation, competition designed against
+leaderboard demotivation risks, and institutional governance in one
+instrumented artefact.
+Contribution: a gamified, QR/NFC checkpoint-based mobile application that
+turns the campus into a fitness instrument — participatory, auditable,
+and governable.</a:t>
             </a:r>
             <a:endParaRPr lang="en-US" dirty="0">
               <a:solidFill>
@@ -10007,7 +10029,22 @@
                 <a:latin typeface="Times New Roman" panose="02020603050405020304" pitchFamily="18" charset="0"/>
                 <a:cs typeface="Times New Roman" panose="02020603050405020304" pitchFamily="18" charset="0"/>
               </a:rPr>
-              <a:t>Aims and Objectives</a:t>
+              <a:t>Aims and Objectives
+Aim
+To design, develop and evaluate a gamified, checkpoint-based mobile
+fitness application that promotes sustained physical activity within a
+university campus.
+Specific objectives
+1. Analyse student fitness behaviour and determine system requirements
+2. Design a user-friendly mobile application interface
+3. Implement secure student registration and authentication
+4. Design and deploy QR/NFC-based checkpoint validation mechanisms
+5. Develop a dynamic points allocation algorithm
+6. Integrate leaderboard functionality for competitive ranking
+7. Implement a badge and achievement reward system
+8. Design an administrative dashboard for system management
+9. Test system usability, performance, and scalability
+10. Evaluate user engagement through pilot testing</a:t>
             </a:r>
             <a:endParaRPr lang="en-US" dirty="0">
               <a:solidFill>
@@ -10225,7 +10262,21 @@
                 <a:latin typeface="Times New Roman" panose="02020603050405020304" pitchFamily="18" charset="0"/>
                 <a:cs typeface="Times New Roman" panose="02020603050405020304" pitchFamily="18" charset="0"/>
               </a:rPr>
-              <a:t>Related Work</a:t>
+              <a:t>Related Work
+Self-determination theory — points as competence feedback, not
+compliance payment; relatedness through clubs and crews (Ryan &amp; Deci, 2000).
+Flow theory — four difficulty tiers (easy/medium/hard/epic) keep
+challenge matched to ability (Csikszentmihalyi, 1990).
+Sustainability — novelty decay is the dominant failure mode; campus
+content must be continuously administered (Althoff et al., 2016;
+Li et al., 2021).
+Location-based precedent — Pokémon Go reached least-active users most
+(Althoff et al., 2016), with decay later (Li et al., 2021).
+Attrition — drop-out is the norm in the first weeks; friction in the
+core action is the failure mode to design against (Linardon &amp;
+Fuller-Tyszkiewicz, 2020).
+Why not sensors alone — equity, privacy, attribution, and portable
+codebase rule out a sensor-first architecture (Section 2.9.1).</a:t>
             </a:r>
             <a:endParaRPr lang="en-US" dirty="0"/>
           </a:p>
@@ -10426,7 +10477,20 @@
                 <a:latin typeface="Times New Roman" panose="02020603050405020304" pitchFamily="18" charset="0"/>
                 <a:cs typeface="Times New Roman" panose="02020603050405020304" pitchFamily="18" charset="0"/>
               </a:rPr>
-              <a:t>Proposed Solution</a:t>
+              <a:t>Proposed Solution
+Architecture (three tiers)
+• Client: React 19 + TypeScript + Tailwind CSS, Progressive Web App
+  with precached shell.
+• Backend: Supabase / PostgreSQL with row-level security; all reward
+  authority in server-side database functions.
+• Physical: printed QR codes (NFC-ready); same code string as the
+  database checkpoint row.
+Refereed reward economy
+• scan_checkpoint() resolves the checkpoint, enforces an 8-hour
+  per-user cooldown, applies a difficulty multiplier, writes an
+  append-only audit ledger, and recomputes points / level / streak in
+  one transaction.
+• Multipliers: easy ×1.0, medium ×1.3, hard ×1.8, epic ×2.5.</a:t>
             </a:r>
             <a:endParaRPr lang="en-US" dirty="0">
               <a:solidFill>
@@ -10703,7 +10767,21 @@
                 <a:latin typeface="Times New Roman" panose="02020603050405020304" pitchFamily="18" charset="0"/>
                 <a:cs typeface="Times New Roman" panose="02020603050405020304" pitchFamily="18" charset="0"/>
               </a:rPr>
-              <a:t>End Slide</a:t>
+              <a:t>End Slide
+Thank you.
+Summary — six verified findings
+1. Schema-implementation fidelity: 29/29 routes, 0 console errors.
+2. Reward-path correctness: 9/9 end-to-end checks, including
+   cooldown rejection.
+3. Points economy verified under simulation across casual, regular and
+   committed profiles.
+4. Interface fidelity to the design specification: mean 0.910 over
+   19 comparable screens.
+5. No high-severity usability findings on heuristic inspection.
+6. Single-codebase PWA: ~207 kB connected first load (cold build
+   25.5 s), offline shell.
+Future work: usability pilot (SUS), NFC / signed rotating codes,
+geofence confirmation, wearable integration, multi-campus federation.</a:t>
             </a:r>
             <a:endParaRPr lang="en-US" dirty="0"/>
           </a:p>

</xml_diff>